<commit_message>
save current gen files
</commit_message>
<xml_diff>
--- a/dt100/bugatti-qos-architecture.pptx
+++ b/dt100/bugatti-qos-architecture.pptx
@@ -4996,7 +4996,7 @@
           </a:ln>
         </p:spPr>
         <p:txBody>
-          <a:bodyPr spcFirstLastPara="1" wrap="none" lIns="91425" tIns="45700" rIns="91425" bIns="45700" anchor="t" anchorCtr="0">
+          <a:bodyPr spcFirstLastPara="1" wrap="square" lIns="91425" tIns="45700" rIns="91425" bIns="45700" anchor="t" anchorCtr="0">
             <a:noAutofit/>
           </a:bodyPr>
           <a:lstStyle/>
@@ -5009,7 +5009,7 @@
                 <a:spcPts val="0"/>
               </a:spcBef>
               <a:spcAft>
-                <a:spcPts val="300"/>
+                <a:spcPts val="200"/>
               </a:spcAft>
               <a:buClr>
                 <a:srgbClr val="051830"/>
@@ -5040,13 +5040,13 @@
           <a:p>
             <a:pPr>
               <a:spcAft>
-                <a:spcPts val="300"/>
+                <a:spcPts val="200"/>
               </a:spcAft>
             </a:pPr>
             <a:r>
               <a:rPr sz="1300">
                 <a:solidFill>
-                  <a:srgbClr val="556677"/>
+                  <a:srgbClr val="051830"/>
                 </a:solidFill>
                 <a:latin typeface="Arial"/>
               </a:rPr>
@@ -5405,7 +5405,7 @@
         </p:blipFill>
         <p:spPr>
           <a:xfrm>
-            <a:off x="365760" y="1538547"/>
+            <a:off x="365760" y="1693995"/>
             <a:ext cx="8412480" cy="3186545"/>
           </a:xfrm>
           <a:prstGeom prst="rect">
@@ -5466,7 +5466,7 @@
           </a:ln>
         </p:spPr>
         <p:txBody>
-          <a:bodyPr spcFirstLastPara="1" wrap="none" lIns="91425" tIns="45700" rIns="91425" bIns="45700" anchor="t" anchorCtr="0">
+          <a:bodyPr spcFirstLastPara="1" wrap="square" lIns="91425" tIns="45700" rIns="91425" bIns="45700" anchor="t" anchorCtr="0">
             <a:noAutofit/>
           </a:bodyPr>
           <a:lstStyle/>
@@ -5479,7 +5479,7 @@
                 <a:spcPts val="0"/>
               </a:spcBef>
               <a:spcAft>
-                <a:spcPts val="300"/>
+                <a:spcPts val="200"/>
               </a:spcAft>
               <a:buClr>
                 <a:srgbClr val="051830"/>
@@ -5859,7 +5859,7 @@
         </p:blipFill>
         <p:spPr>
           <a:xfrm>
-            <a:off x="365760" y="1538547"/>
+            <a:off x="365760" y="1693995"/>
             <a:ext cx="8412480" cy="3186545"/>
           </a:xfrm>
           <a:prstGeom prst="rect">
@@ -5920,7 +5920,7 @@
           </a:ln>
         </p:spPr>
         <p:txBody>
-          <a:bodyPr spcFirstLastPara="1" wrap="none" lIns="91425" tIns="45700" rIns="91425" bIns="45700" anchor="t" anchorCtr="0">
+          <a:bodyPr spcFirstLastPara="1" wrap="square" lIns="91425" tIns="45700" rIns="91425" bIns="45700" anchor="t" anchorCtr="0">
             <a:noAutofit/>
           </a:bodyPr>
           <a:lstStyle/>
@@ -5933,7 +5933,7 @@
                 <a:spcPts val="0"/>
               </a:spcBef>
               <a:spcAft>
-                <a:spcPts val="300"/>
+                <a:spcPts val="200"/>
               </a:spcAft>
               <a:buClr>
                 <a:srgbClr val="051830"/>
@@ -6313,7 +6313,7 @@
         </p:blipFill>
         <p:spPr>
           <a:xfrm>
-            <a:off x="365760" y="1538547"/>
+            <a:off x="365760" y="1693995"/>
             <a:ext cx="8412480" cy="3186545"/>
           </a:xfrm>
           <a:prstGeom prst="rect">
@@ -6374,7 +6374,7 @@
           </a:ln>
         </p:spPr>
         <p:txBody>
-          <a:bodyPr spcFirstLastPara="1" wrap="none" lIns="91425" tIns="45700" rIns="91425" bIns="45700" anchor="t" anchorCtr="0">
+          <a:bodyPr spcFirstLastPara="1" wrap="square" lIns="91425" tIns="45700" rIns="91425" bIns="45700" anchor="t" anchorCtr="0">
             <a:noAutofit/>
           </a:bodyPr>
           <a:lstStyle/>
@@ -6387,7 +6387,7 @@
                 <a:spcPts val="0"/>
               </a:spcBef>
               <a:spcAft>
-                <a:spcPts val="300"/>
+                <a:spcPts val="200"/>
               </a:spcAft>
               <a:buClr>
                 <a:srgbClr val="051830"/>
@@ -6767,7 +6767,7 @@
         </p:blipFill>
         <p:spPr>
           <a:xfrm>
-            <a:off x="365760" y="1538547"/>
+            <a:off x="365760" y="1693995"/>
             <a:ext cx="8412480" cy="3186545"/>
           </a:xfrm>
           <a:prstGeom prst="rect">

</xml_diff>